<commit_message>
docs: embed sales and negotiation photos in commercial training guide
</commit_message>
<xml_diff>
--- a/guide_commercial_gainable.pptx
+++ b/guide_commercial_gainable.pptx
@@ -3112,7 +3112,7 @@
         <p:spPr>
           <a:xfrm>
             <a:off x="731520" y="2011680"/>
-            <a:ext cx="10698480" cy="4114800"/>
+            <a:ext cx="5943600" cy="4114800"/>
           </a:xfrm>
           <a:prstGeom prst="rect">
             <a:avLst/>
@@ -3209,6 +3209,30 @@
           <a:xfrm>
             <a:off x="731520" y="914400"/>
             <a:ext cx="2377440" cy="713232"/>
+          </a:xfrm>
+          <a:prstGeom prst="rect">
+            <a:avLst/>
+          </a:prstGeom>
+        </p:spPr>
+      </p:pic>
+      <p:pic>
+        <p:nvPicPr>
+          <p:cNvPr id="4" name="Picture 3" descr="sales_meeting.png"/>
+          <p:cNvPicPr>
+            <a:picLocks noChangeAspect="1"/>
+          </p:cNvPicPr>
+          <p:nvPr/>
+        </p:nvPicPr>
+        <p:blipFill>
+          <a:blip r:embed="rId3"/>
+          <a:stretch>
+            <a:fillRect/>
+          </a:stretch>
+        </p:blipFill>
+        <p:spPr>
+          <a:xfrm>
+            <a:off x="6705295" y="0"/>
+            <a:ext cx="5486400" cy="6858000"/>
           </a:xfrm>
           <a:prstGeom prst="rect">
             <a:avLst/>
@@ -4841,7 +4865,7 @@
         <p:spPr>
           <a:xfrm>
             <a:off x="731520" y="1645920"/>
-            <a:ext cx="10698480" cy="4572000"/>
+            <a:ext cx="5943600" cy="4572000"/>
           </a:xfrm>
           <a:prstGeom prst="rect">
             <a:avLst/>
@@ -4858,7 +4882,7 @@
               <a:spcAft>
                 <a:spcPts val="1500"/>
               </a:spcAft>
-              <a:defRPr sz="2800" b="1">
+              <a:defRPr sz="2400" b="1">
                 <a:solidFill>
                   <a:srgbClr val="FFFFFF"/>
                 </a:solidFill>
@@ -4866,7 +4890,7 @@
               </a:defRPr>
             </a:pPr>
             <a:r>
-              <a:t>Votre mission : Devenir le partenaire croissance des artisans</a:t>
+              <a:t>Votre mission : Devenir le partenaire croissance</a:t>
             </a:r>
           </a:p>
           <a:p>
@@ -4874,7 +4898,7 @@
               <a:spcAft>
                 <a:spcPts val="800"/>
               </a:spcAft>
-              <a:defRPr sz="1400">
+              <a:defRPr sz="1250">
                 <a:latin typeface="Arial"/>
               </a:defRPr>
             </a:pPr>
@@ -4892,7 +4916,7 @@
                   <a:srgbClr val="64748B"/>
                 </a:solidFill>
               </a:rPr>
-              <a:t>Vous ne proposez pas de la dépense publicitaire volatile, mais un investissement de visibilité locale durable et éthique sans commission.</a:t>
+              <a:t>Investissement de visibilité locale durable et éthique.</a:t>
             </a:r>
           </a:p>
           <a:p>
@@ -4900,7 +4924,7 @@
               <a:spcAft>
                 <a:spcPts val="800"/>
               </a:spcAft>
-              <a:defRPr sz="1400">
+              <a:defRPr sz="1250">
                 <a:latin typeface="Arial"/>
               </a:defRPr>
             </a:pPr>
@@ -4910,7 +4934,7 @@
                   <a:srgbClr val="FFFFFF"/>
                 </a:solidFill>
               </a:rPr>
-              <a:t>✔ Une adhésion simple à rentabiliser : </a:t>
+              <a:t>✔ ROI immédiat : </a:t>
             </a:r>
             <a:r>
               <a:rPr b="0">
@@ -4918,7 +4942,7 @@
                   <a:srgbClr val="64748B"/>
                 </a:solidFill>
               </a:rPr>
-              <a:t>Pour vos prospects, une seule vente générée par Gainable.fr couvre largement le coût de l'abonnement annuel.</a:t>
+              <a:t>Une adhésion rentabilisée dès le premier chantier signé.</a:t>
             </a:r>
           </a:p>
           <a:p>
@@ -4926,7 +4950,7 @@
               <a:spcAft>
                 <a:spcPts val="800"/>
               </a:spcAft>
-              <a:defRPr sz="1400">
+              <a:defRPr sz="1250">
                 <a:latin typeface="Arial"/>
               </a:defRPr>
             </a:pPr>
@@ -4936,7 +4960,7 @@
                   <a:srgbClr val="FFFFFF"/>
                 </a:solidFill>
               </a:rPr>
-              <a:t>✔ Des outils de prospection libres : </a:t>
+              <a:t>✔ Leviers de prospection libres : </a:t>
             </a:r>
             <a:r>
               <a:rPr b="0">
@@ -4944,7 +4968,7 @@
                   <a:srgbClr val="64748B"/>
                 </a:solidFill>
               </a:rPr>
-              <a:t>Utilisez LinkedIn, l'emailing ciblé ou le phoning. Coordonnez vos publicités Meta avec Exceeddigital pour démultiplier vos résultats.</a:t>
+              <a:t>Utilisez LinkedIn, phoning, et campagnes Meta coordonnées avec Exceeddigital.</a:t>
             </a:r>
           </a:p>
           <a:p>
@@ -4952,7 +4976,7 @@
               <a:spcAft>
                 <a:spcPts val="800"/>
               </a:spcAft>
-              <a:defRPr sz="1400">
+              <a:defRPr sz="1250">
                 <a:latin typeface="Arial"/>
               </a:defRPr>
             </a:pPr>
@@ -4962,7 +4986,7 @@
                   <a:srgbClr val="FFFFFF"/>
                 </a:solidFill>
               </a:rPr>
-              <a:t>✔ Commissions motivantes : </a:t>
+              <a:t>✔ Commissions attractives : </a:t>
             </a:r>
             <a:r>
               <a:rPr b="0">
@@ -4970,11 +4994,35 @@
                   <a:srgbClr val="64748B"/>
                 </a:solidFill>
               </a:rPr>
-              <a:t>En tant que consultant, vous bénéficiez d'une commission attractive calculée en temps réel sur la valeur finale de chaque abonnement vendu.</a:t>
-            </a:r>
-          </a:p>
-        </p:txBody>
-      </p:sp>
+              <a:t>Rémunération calculée en temps réel à 17% pour Emy Marty.</a:t>
+            </a:r>
+          </a:p>
+        </p:txBody>
+      </p:sp>
+      <p:pic>
+        <p:nvPicPr>
+          <p:cNvPr id="3" name="Picture 2" descr="sales_handshake.png"/>
+          <p:cNvPicPr>
+            <a:picLocks noChangeAspect="1"/>
+          </p:cNvPicPr>
+          <p:nvPr/>
+        </p:nvPicPr>
+        <p:blipFill>
+          <a:blip r:embed="rId2"/>
+          <a:stretch>
+            <a:fillRect/>
+          </a:stretch>
+        </p:blipFill>
+        <p:spPr>
+          <a:xfrm>
+            <a:off x="6705295" y="0"/>
+            <a:ext cx="5486400" cy="6858000"/>
+          </a:xfrm>
+          <a:prstGeom prst="rect">
+            <a:avLst/>
+          </a:prstGeom>
+        </p:spPr>
+      </p:pic>
     </p:spTree>
   </p:cSld>
   <p:clrMapOvr>

</xml_diff>

<commit_message>
feat(commercial): Playbook CVC complet v2 - Scripts, objections, mindset, ecosysteme maillage, comparatif plateformes - Correction: 0 revente de contact (le client choisit directement)
</commit_message>
<xml_diff>
--- a/guide_commercial_gainable.pptx
+++ b/guide_commercial_gainable.pptx
@@ -5,16 +5,16 @@
     <p:sldMasterId id="2147483648" r:id="rId1"/>
   </p:sldMasterIdLst>
   <p:sldIdLst>
-    <p:sldId id="256" r:id="rId7"/>
-    <p:sldId id="257" r:id="rId8"/>
-    <p:sldId id="258" r:id="rId9"/>
-    <p:sldId id="259" r:id="rId10"/>
-    <p:sldId id="260" r:id="rId11"/>
-    <p:sldId id="261" r:id="rId12"/>
-    <p:sldId id="262" r:id="rId13"/>
-    <p:sldId id="263" r:id="rId14"/>
+    <p:sldId id="256" r:id="rId2"/>
+    <p:sldId id="257" r:id="rId3"/>
+    <p:sldId id="258" r:id="rId4"/>
+    <p:sldId id="259" r:id="rId5"/>
+    <p:sldId id="260" r:id="rId6"/>
+    <p:sldId id="261" r:id="rId7"/>
+    <p:sldId id="262" r:id="rId8"/>
+    <p:sldId id="263" r:id="rId9"/>
   </p:sldIdLst>
-  <p:sldSz cx="12191695" cy="6858000" type="screen4x3"/>
+  <p:sldSz cx="12192000" cy="6858000"/>
   <p:notesSz cx="6858000" cy="9144000"/>
   <p:defaultTextStyle>
     <a:defPPr>
@@ -111,6 +111,22 @@
       </a:defRPr>
     </a:lvl9pPr>
   </p:defaultTextStyle>
+  <p:extLst>
+    <p:ext uri="{EFAFB233-063F-42B5-8137-9DF3F51BA10A}">
+      <p15:sldGuideLst xmlns:p15="http://schemas.microsoft.com/office/powerpoint/2012/main">
+        <p15:guide id="1" orient="horz" pos="2160">
+          <p15:clr>
+            <a:srgbClr val="A4A3A4"/>
+          </p15:clr>
+        </p15:guide>
+        <p15:guide id="2" pos="2880">
+          <p15:clr>
+            <a:srgbClr val="A4A3A4"/>
+          </p15:clr>
+        </p15:guide>
+      </p15:sldGuideLst>
+    </p:ext>
+  </p:extLst>
 </p:presentation>
 </file>
 
@@ -152,10 +168,9 @@
           <a:lstStyle/>
           <a:p>
             <a:r>
-              <a:rPr lang="en-US" smtClean="0"/>
+              <a:rPr lang="en-US"/>
               <a:t>Click to edit Master title style</a:t>
             </a:r>
-            <a:endParaRPr lang="en-US"/>
           </a:p>
         </p:txBody>
       </p:sp>
@@ -271,10 +286,9 @@
           </a:lstStyle>
           <a:p>
             <a:r>
-              <a:rPr lang="en-US" smtClean="0"/>
+              <a:rPr lang="en-US"/>
               <a:t>Click to edit Master subtitle style</a:t>
             </a:r>
-            <a:endParaRPr lang="en-US"/>
           </a:p>
         </p:txBody>
       </p:sp>
@@ -295,7 +309,7 @@
           <a:p>
             <a:fld id="{5BCAD085-E8A6-8845-BD4E-CB4CCA059FC4}" type="datetimeFigureOut">
               <a:rPr lang="en-US" smtClean="0"/>
-              <a:t>1/27/13</a:t>
+              <a:t>6/23/2026</a:t>
             </a:fld>
             <a:endParaRPr lang="en-US"/>
           </a:p>
@@ -337,7 +351,7 @@
           <a:p>
             <a:fld id="{C1FF6DA9-008F-8B48-92A6-B652298478BF}" type="slidenum">
               <a:rPr lang="en-US" smtClean="0"/>
-              <a:t>‹#›</a:t>
+              <a:t>‹N°›</a:t>
             </a:fld>
             <a:endParaRPr lang="en-US"/>
           </a:p>
@@ -389,10 +403,9 @@
           <a:lstStyle/>
           <a:p>
             <a:r>
-              <a:rPr lang="en-US" smtClean="0"/>
+              <a:rPr lang="en-US"/>
               <a:t>Click to edit Master title style</a:t>
             </a:r>
-            <a:endParaRPr lang="en-US"/>
           </a:p>
         </p:txBody>
       </p:sp>
@@ -413,38 +426,37 @@
           <a:p>
             <a:pPr lvl="0"/>
             <a:r>
-              <a:rPr lang="en-US" smtClean="0"/>
+              <a:rPr lang="en-US"/>
               <a:t>Click to edit Master text styles</a:t>
             </a:r>
           </a:p>
           <a:p>
             <a:pPr lvl="1"/>
             <a:r>
-              <a:rPr lang="en-US" smtClean="0"/>
+              <a:rPr lang="en-US"/>
               <a:t>Second level</a:t>
             </a:r>
           </a:p>
           <a:p>
             <a:pPr lvl="2"/>
             <a:r>
-              <a:rPr lang="en-US" smtClean="0"/>
+              <a:rPr lang="en-US"/>
               <a:t>Third level</a:t>
             </a:r>
           </a:p>
           <a:p>
             <a:pPr lvl="3"/>
             <a:r>
-              <a:rPr lang="en-US" smtClean="0"/>
+              <a:rPr lang="en-US"/>
               <a:t>Fourth level</a:t>
             </a:r>
           </a:p>
           <a:p>
             <a:pPr lvl="4"/>
             <a:r>
-              <a:rPr lang="en-US" smtClean="0"/>
+              <a:rPr lang="en-US"/>
               <a:t>Fifth level</a:t>
             </a:r>
-            <a:endParaRPr lang="en-US"/>
           </a:p>
         </p:txBody>
       </p:sp>
@@ -465,7 +477,7 @@
           <a:p>
             <a:fld id="{5BCAD085-E8A6-8845-BD4E-CB4CCA059FC4}" type="datetimeFigureOut">
               <a:rPr lang="en-US" smtClean="0"/>
-              <a:t>1/27/13</a:t>
+              <a:t>6/23/2026</a:t>
             </a:fld>
             <a:endParaRPr lang="en-US"/>
           </a:p>
@@ -507,7 +519,7 @@
           <a:p>
             <a:fld id="{C1FF6DA9-008F-8B48-92A6-B652298478BF}" type="slidenum">
               <a:rPr lang="en-US" smtClean="0"/>
-              <a:t>‹#›</a:t>
+              <a:t>‹N°›</a:t>
             </a:fld>
             <a:endParaRPr lang="en-US"/>
           </a:p>
@@ -564,10 +576,9 @@
           <a:lstStyle/>
           <a:p>
             <a:r>
-              <a:rPr lang="en-US" smtClean="0"/>
+              <a:rPr lang="en-US"/>
               <a:t>Click to edit Master title style</a:t>
             </a:r>
-            <a:endParaRPr lang="en-US"/>
           </a:p>
         </p:txBody>
       </p:sp>
@@ -593,38 +604,37 @@
           <a:p>
             <a:pPr lvl="0"/>
             <a:r>
-              <a:rPr lang="en-US" smtClean="0"/>
+              <a:rPr lang="en-US"/>
               <a:t>Click to edit Master text styles</a:t>
             </a:r>
           </a:p>
           <a:p>
             <a:pPr lvl="1"/>
             <a:r>
-              <a:rPr lang="en-US" smtClean="0"/>
+              <a:rPr lang="en-US"/>
               <a:t>Second level</a:t>
             </a:r>
           </a:p>
           <a:p>
             <a:pPr lvl="2"/>
             <a:r>
-              <a:rPr lang="en-US" smtClean="0"/>
+              <a:rPr lang="en-US"/>
               <a:t>Third level</a:t>
             </a:r>
           </a:p>
           <a:p>
             <a:pPr lvl="3"/>
             <a:r>
-              <a:rPr lang="en-US" smtClean="0"/>
+              <a:rPr lang="en-US"/>
               <a:t>Fourth level</a:t>
             </a:r>
           </a:p>
           <a:p>
             <a:pPr lvl="4"/>
             <a:r>
-              <a:rPr lang="en-US" smtClean="0"/>
+              <a:rPr lang="en-US"/>
               <a:t>Fifth level</a:t>
             </a:r>
-            <a:endParaRPr lang="en-US"/>
           </a:p>
         </p:txBody>
       </p:sp>
@@ -645,7 +655,7 @@
           <a:p>
             <a:fld id="{5BCAD085-E8A6-8845-BD4E-CB4CCA059FC4}" type="datetimeFigureOut">
               <a:rPr lang="en-US" smtClean="0"/>
-              <a:t>1/27/13</a:t>
+              <a:t>6/23/2026</a:t>
             </a:fld>
             <a:endParaRPr lang="en-US"/>
           </a:p>
@@ -687,7 +697,7 @@
           <a:p>
             <a:fld id="{C1FF6DA9-008F-8B48-92A6-B652298478BF}" type="slidenum">
               <a:rPr lang="en-US" smtClean="0"/>
-              <a:t>‹#›</a:t>
+              <a:t>‹N°›</a:t>
             </a:fld>
             <a:endParaRPr lang="en-US"/>
           </a:p>
@@ -739,10 +749,9 @@
           <a:lstStyle/>
           <a:p>
             <a:r>
-              <a:rPr lang="en-US" smtClean="0"/>
+              <a:rPr lang="en-US"/>
               <a:t>Click to edit Master title style</a:t>
             </a:r>
-            <a:endParaRPr lang="en-US"/>
           </a:p>
         </p:txBody>
       </p:sp>
@@ -763,38 +772,37 @@
           <a:p>
             <a:pPr lvl="0"/>
             <a:r>
-              <a:rPr lang="en-US" smtClean="0"/>
+              <a:rPr lang="en-US"/>
               <a:t>Click to edit Master text styles</a:t>
             </a:r>
           </a:p>
           <a:p>
             <a:pPr lvl="1"/>
             <a:r>
-              <a:rPr lang="en-US" smtClean="0"/>
+              <a:rPr lang="en-US"/>
               <a:t>Second level</a:t>
             </a:r>
           </a:p>
           <a:p>
             <a:pPr lvl="2"/>
             <a:r>
-              <a:rPr lang="en-US" smtClean="0"/>
+              <a:rPr lang="en-US"/>
               <a:t>Third level</a:t>
             </a:r>
           </a:p>
           <a:p>
             <a:pPr lvl="3"/>
             <a:r>
-              <a:rPr lang="en-US" smtClean="0"/>
+              <a:rPr lang="en-US"/>
               <a:t>Fourth level</a:t>
             </a:r>
           </a:p>
           <a:p>
             <a:pPr lvl="4"/>
             <a:r>
-              <a:rPr lang="en-US" smtClean="0"/>
+              <a:rPr lang="en-US"/>
               <a:t>Fifth level</a:t>
             </a:r>
-            <a:endParaRPr lang="en-US"/>
           </a:p>
         </p:txBody>
       </p:sp>
@@ -815,7 +823,7 @@
           <a:p>
             <a:fld id="{5BCAD085-E8A6-8845-BD4E-CB4CCA059FC4}" type="datetimeFigureOut">
               <a:rPr lang="en-US" smtClean="0"/>
-              <a:t>1/27/13</a:t>
+              <a:t>6/23/2026</a:t>
             </a:fld>
             <a:endParaRPr lang="en-US"/>
           </a:p>
@@ -857,7 +865,7 @@
           <a:p>
             <a:fld id="{C1FF6DA9-008F-8B48-92A6-B652298478BF}" type="slidenum">
               <a:rPr lang="en-US" smtClean="0"/>
-              <a:t>‹#›</a:t>
+              <a:t>‹N°›</a:t>
             </a:fld>
             <a:endParaRPr lang="en-US"/>
           </a:p>
@@ -918,10 +926,9 @@
           </a:lstStyle>
           <a:p>
             <a:r>
-              <a:rPr lang="en-US" smtClean="0"/>
+              <a:rPr lang="en-US"/>
               <a:t>Click to edit Master title style</a:t>
             </a:r>
-            <a:endParaRPr lang="en-US"/>
           </a:p>
         </p:txBody>
       </p:sp>
@@ -1038,7 +1045,7 @@
           <a:p>
             <a:pPr lvl="0"/>
             <a:r>
-              <a:rPr lang="en-US" smtClean="0"/>
+              <a:rPr lang="en-US"/>
               <a:t>Click to edit Master text styles</a:t>
             </a:r>
           </a:p>
@@ -1061,7 +1068,7 @@
           <a:p>
             <a:fld id="{5BCAD085-E8A6-8845-BD4E-CB4CCA059FC4}" type="datetimeFigureOut">
               <a:rPr lang="en-US" smtClean="0"/>
-              <a:t>1/27/13</a:t>
+              <a:t>6/23/2026</a:t>
             </a:fld>
             <a:endParaRPr lang="en-US"/>
           </a:p>
@@ -1103,7 +1110,7 @@
           <a:p>
             <a:fld id="{C1FF6DA9-008F-8B48-92A6-B652298478BF}" type="slidenum">
               <a:rPr lang="en-US" smtClean="0"/>
-              <a:t>‹#›</a:t>
+              <a:t>‹N°›</a:t>
             </a:fld>
             <a:endParaRPr lang="en-US"/>
           </a:p>
@@ -1155,10 +1162,9 @@
           <a:lstStyle/>
           <a:p>
             <a:r>
-              <a:rPr lang="en-US" smtClean="0"/>
+              <a:rPr lang="en-US"/>
               <a:t>Click to edit Master title style</a:t>
             </a:r>
-            <a:endParaRPr lang="en-US"/>
           </a:p>
         </p:txBody>
       </p:sp>
@@ -1212,38 +1218,37 @@
           <a:p>
             <a:pPr lvl="0"/>
             <a:r>
-              <a:rPr lang="en-US" smtClean="0"/>
+              <a:rPr lang="en-US"/>
               <a:t>Click to edit Master text styles</a:t>
             </a:r>
           </a:p>
           <a:p>
             <a:pPr lvl="1"/>
             <a:r>
-              <a:rPr lang="en-US" smtClean="0"/>
+              <a:rPr lang="en-US"/>
               <a:t>Second level</a:t>
             </a:r>
           </a:p>
           <a:p>
             <a:pPr lvl="2"/>
             <a:r>
-              <a:rPr lang="en-US" smtClean="0"/>
+              <a:rPr lang="en-US"/>
               <a:t>Third level</a:t>
             </a:r>
           </a:p>
           <a:p>
             <a:pPr lvl="3"/>
             <a:r>
-              <a:rPr lang="en-US" smtClean="0"/>
+              <a:rPr lang="en-US"/>
               <a:t>Fourth level</a:t>
             </a:r>
           </a:p>
           <a:p>
             <a:pPr lvl="4"/>
             <a:r>
-              <a:rPr lang="en-US" smtClean="0"/>
+              <a:rPr lang="en-US"/>
               <a:t>Fifth level</a:t>
             </a:r>
-            <a:endParaRPr lang="en-US"/>
           </a:p>
         </p:txBody>
       </p:sp>
@@ -1297,38 +1302,37 @@
           <a:p>
             <a:pPr lvl="0"/>
             <a:r>
-              <a:rPr lang="en-US" smtClean="0"/>
+              <a:rPr lang="en-US"/>
               <a:t>Click to edit Master text styles</a:t>
             </a:r>
           </a:p>
           <a:p>
             <a:pPr lvl="1"/>
             <a:r>
-              <a:rPr lang="en-US" smtClean="0"/>
+              <a:rPr lang="en-US"/>
               <a:t>Second level</a:t>
             </a:r>
           </a:p>
           <a:p>
             <a:pPr lvl="2"/>
             <a:r>
-              <a:rPr lang="en-US" smtClean="0"/>
+              <a:rPr lang="en-US"/>
               <a:t>Third level</a:t>
             </a:r>
           </a:p>
           <a:p>
             <a:pPr lvl="3"/>
             <a:r>
-              <a:rPr lang="en-US" smtClean="0"/>
+              <a:rPr lang="en-US"/>
               <a:t>Fourth level</a:t>
             </a:r>
           </a:p>
           <a:p>
             <a:pPr lvl="4"/>
             <a:r>
-              <a:rPr lang="en-US" smtClean="0"/>
+              <a:rPr lang="en-US"/>
               <a:t>Fifth level</a:t>
             </a:r>
-            <a:endParaRPr lang="en-US"/>
           </a:p>
         </p:txBody>
       </p:sp>
@@ -1349,7 +1353,7 @@
           <a:p>
             <a:fld id="{5BCAD085-E8A6-8845-BD4E-CB4CCA059FC4}" type="datetimeFigureOut">
               <a:rPr lang="en-US" smtClean="0"/>
-              <a:t>1/27/13</a:t>
+              <a:t>6/23/2026</a:t>
             </a:fld>
             <a:endParaRPr lang="en-US"/>
           </a:p>
@@ -1391,7 +1395,7 @@
           <a:p>
             <a:fld id="{C1FF6DA9-008F-8B48-92A6-B652298478BF}" type="slidenum">
               <a:rPr lang="en-US" smtClean="0"/>
-              <a:t>‹#›</a:t>
+              <a:t>‹N°›</a:t>
             </a:fld>
             <a:endParaRPr lang="en-US"/>
           </a:p>
@@ -1447,10 +1451,9 @@
           </a:lstStyle>
           <a:p>
             <a:r>
-              <a:rPr lang="en-US" smtClean="0"/>
+              <a:rPr lang="en-US"/>
               <a:t>Click to edit Master title style</a:t>
             </a:r>
-            <a:endParaRPr lang="en-US"/>
           </a:p>
         </p:txBody>
       </p:sp>
@@ -1513,7 +1516,7 @@
           <a:p>
             <a:pPr lvl="0"/>
             <a:r>
-              <a:rPr lang="en-US" smtClean="0"/>
+              <a:rPr lang="en-US"/>
               <a:t>Click to edit Master text styles</a:t>
             </a:r>
           </a:p>
@@ -1569,38 +1572,37 @@
           <a:p>
             <a:pPr lvl="0"/>
             <a:r>
-              <a:rPr lang="en-US" smtClean="0"/>
+              <a:rPr lang="en-US"/>
               <a:t>Click to edit Master text styles</a:t>
             </a:r>
           </a:p>
           <a:p>
             <a:pPr lvl="1"/>
             <a:r>
-              <a:rPr lang="en-US" smtClean="0"/>
+              <a:rPr lang="en-US"/>
               <a:t>Second level</a:t>
             </a:r>
           </a:p>
           <a:p>
             <a:pPr lvl="2"/>
             <a:r>
-              <a:rPr lang="en-US" smtClean="0"/>
+              <a:rPr lang="en-US"/>
               <a:t>Third level</a:t>
             </a:r>
           </a:p>
           <a:p>
             <a:pPr lvl="3"/>
             <a:r>
-              <a:rPr lang="en-US" smtClean="0"/>
+              <a:rPr lang="en-US"/>
               <a:t>Fourth level</a:t>
             </a:r>
           </a:p>
           <a:p>
             <a:pPr lvl="4"/>
             <a:r>
-              <a:rPr lang="en-US" smtClean="0"/>
+              <a:rPr lang="en-US"/>
               <a:t>Fifth level</a:t>
             </a:r>
-            <a:endParaRPr lang="en-US"/>
           </a:p>
         </p:txBody>
       </p:sp>
@@ -1663,7 +1665,7 @@
           <a:p>
             <a:pPr lvl="0"/>
             <a:r>
-              <a:rPr lang="en-US" smtClean="0"/>
+              <a:rPr lang="en-US"/>
               <a:t>Click to edit Master text styles</a:t>
             </a:r>
           </a:p>
@@ -1719,38 +1721,37 @@
           <a:p>
             <a:pPr lvl="0"/>
             <a:r>
-              <a:rPr lang="en-US" smtClean="0"/>
+              <a:rPr lang="en-US"/>
               <a:t>Click to edit Master text styles</a:t>
             </a:r>
           </a:p>
           <a:p>
             <a:pPr lvl="1"/>
             <a:r>
-              <a:rPr lang="en-US" smtClean="0"/>
+              <a:rPr lang="en-US"/>
               <a:t>Second level</a:t>
             </a:r>
           </a:p>
           <a:p>
             <a:pPr lvl="2"/>
             <a:r>
-              <a:rPr lang="en-US" smtClean="0"/>
+              <a:rPr lang="en-US"/>
               <a:t>Third level</a:t>
             </a:r>
           </a:p>
           <a:p>
             <a:pPr lvl="3"/>
             <a:r>
-              <a:rPr lang="en-US" smtClean="0"/>
+              <a:rPr lang="en-US"/>
               <a:t>Fourth level</a:t>
             </a:r>
           </a:p>
           <a:p>
             <a:pPr lvl="4"/>
             <a:r>
-              <a:rPr lang="en-US" smtClean="0"/>
+              <a:rPr lang="en-US"/>
               <a:t>Fifth level</a:t>
             </a:r>
-            <a:endParaRPr lang="en-US"/>
           </a:p>
         </p:txBody>
       </p:sp>
@@ -1771,7 +1772,7 @@
           <a:p>
             <a:fld id="{5BCAD085-E8A6-8845-BD4E-CB4CCA059FC4}" type="datetimeFigureOut">
               <a:rPr lang="en-US" smtClean="0"/>
-              <a:t>1/27/13</a:t>
+              <a:t>6/23/2026</a:t>
             </a:fld>
             <a:endParaRPr lang="en-US"/>
           </a:p>
@@ -1813,7 +1814,7 @@
           <a:p>
             <a:fld id="{C1FF6DA9-008F-8B48-92A6-B652298478BF}" type="slidenum">
               <a:rPr lang="en-US" smtClean="0"/>
-              <a:t>‹#›</a:t>
+              <a:t>‹N°›</a:t>
             </a:fld>
             <a:endParaRPr lang="en-US"/>
           </a:p>
@@ -1865,10 +1866,9 @@
           <a:lstStyle/>
           <a:p>
             <a:r>
-              <a:rPr lang="en-US" smtClean="0"/>
+              <a:rPr lang="en-US"/>
               <a:t>Click to edit Master title style</a:t>
             </a:r>
-            <a:endParaRPr lang="en-US"/>
           </a:p>
         </p:txBody>
       </p:sp>
@@ -1889,7 +1889,7 @@
           <a:p>
             <a:fld id="{5BCAD085-E8A6-8845-BD4E-CB4CCA059FC4}" type="datetimeFigureOut">
               <a:rPr lang="en-US" smtClean="0"/>
-              <a:t>1/27/13</a:t>
+              <a:t>6/23/2026</a:t>
             </a:fld>
             <a:endParaRPr lang="en-US"/>
           </a:p>
@@ -1931,7 +1931,7 @@
           <a:p>
             <a:fld id="{C1FF6DA9-008F-8B48-92A6-B652298478BF}" type="slidenum">
               <a:rPr lang="en-US" smtClean="0"/>
-              <a:t>‹#›</a:t>
+              <a:t>‹N°›</a:t>
             </a:fld>
             <a:endParaRPr lang="en-US"/>
           </a:p>
@@ -1984,7 +1984,7 @@
           <a:p>
             <a:fld id="{5BCAD085-E8A6-8845-BD4E-CB4CCA059FC4}" type="datetimeFigureOut">
               <a:rPr lang="en-US" smtClean="0"/>
-              <a:t>1/27/13</a:t>
+              <a:t>6/23/2026</a:t>
             </a:fld>
             <a:endParaRPr lang="en-US"/>
           </a:p>
@@ -2026,7 +2026,7 @@
           <a:p>
             <a:fld id="{C1FF6DA9-008F-8B48-92A6-B652298478BF}" type="slidenum">
               <a:rPr lang="en-US" smtClean="0"/>
-              <a:t>‹#›</a:t>
+              <a:t>‹N°›</a:t>
             </a:fld>
             <a:endParaRPr lang="en-US"/>
           </a:p>
@@ -2087,10 +2087,9 @@
           </a:lstStyle>
           <a:p>
             <a:r>
-              <a:rPr lang="en-US" smtClean="0"/>
+              <a:rPr lang="en-US"/>
               <a:t>Click to edit Master title style</a:t>
             </a:r>
-            <a:endParaRPr lang="en-US"/>
           </a:p>
         </p:txBody>
       </p:sp>
@@ -2144,38 +2143,37 @@
           <a:p>
             <a:pPr lvl="0"/>
             <a:r>
-              <a:rPr lang="en-US" smtClean="0"/>
+              <a:rPr lang="en-US"/>
               <a:t>Click to edit Master text styles</a:t>
             </a:r>
           </a:p>
           <a:p>
             <a:pPr lvl="1"/>
             <a:r>
-              <a:rPr lang="en-US" smtClean="0"/>
+              <a:rPr lang="en-US"/>
               <a:t>Second level</a:t>
             </a:r>
           </a:p>
           <a:p>
             <a:pPr lvl="2"/>
             <a:r>
-              <a:rPr lang="en-US" smtClean="0"/>
+              <a:rPr lang="en-US"/>
               <a:t>Third level</a:t>
             </a:r>
           </a:p>
           <a:p>
             <a:pPr lvl="3"/>
             <a:r>
-              <a:rPr lang="en-US" smtClean="0"/>
+              <a:rPr lang="en-US"/>
               <a:t>Fourth level</a:t>
             </a:r>
           </a:p>
           <a:p>
             <a:pPr lvl="4"/>
             <a:r>
-              <a:rPr lang="en-US" smtClean="0"/>
+              <a:rPr lang="en-US"/>
               <a:t>Fifth level</a:t>
             </a:r>
-            <a:endParaRPr lang="en-US"/>
           </a:p>
         </p:txBody>
       </p:sp>
@@ -2238,7 +2236,7 @@
           <a:p>
             <a:pPr lvl="0"/>
             <a:r>
-              <a:rPr lang="en-US" smtClean="0"/>
+              <a:rPr lang="en-US"/>
               <a:t>Click to edit Master text styles</a:t>
             </a:r>
           </a:p>
@@ -2261,7 +2259,7 @@
           <a:p>
             <a:fld id="{5BCAD085-E8A6-8845-BD4E-CB4CCA059FC4}" type="datetimeFigureOut">
               <a:rPr lang="en-US" smtClean="0"/>
-              <a:t>1/27/13</a:t>
+              <a:t>6/23/2026</a:t>
             </a:fld>
             <a:endParaRPr lang="en-US"/>
           </a:p>
@@ -2303,7 +2301,7 @@
           <a:p>
             <a:fld id="{C1FF6DA9-008F-8B48-92A6-B652298478BF}" type="slidenum">
               <a:rPr lang="en-US" smtClean="0"/>
-              <a:t>‹#›</a:t>
+              <a:t>‹N°›</a:t>
             </a:fld>
             <a:endParaRPr lang="en-US"/>
           </a:p>
@@ -2364,10 +2362,9 @@
           </a:lstStyle>
           <a:p>
             <a:r>
-              <a:rPr lang="en-US" smtClean="0"/>
+              <a:rPr lang="en-US"/>
               <a:t>Click to edit Master title style</a:t>
             </a:r>
-            <a:endParaRPr lang="en-US"/>
           </a:p>
         </p:txBody>
       </p:sp>
@@ -2491,7 +2488,7 @@
           <a:p>
             <a:pPr lvl="0"/>
             <a:r>
-              <a:rPr lang="en-US" smtClean="0"/>
+              <a:rPr lang="en-US"/>
               <a:t>Click to edit Master text styles</a:t>
             </a:r>
           </a:p>
@@ -2514,7 +2511,7 @@
           <a:p>
             <a:fld id="{5BCAD085-E8A6-8845-BD4E-CB4CCA059FC4}" type="datetimeFigureOut">
               <a:rPr lang="en-US" smtClean="0"/>
-              <a:t>1/27/13</a:t>
+              <a:t>6/23/2026</a:t>
             </a:fld>
             <a:endParaRPr lang="en-US"/>
           </a:p>
@@ -2556,7 +2553,7 @@
           <a:p>
             <a:fld id="{C1FF6DA9-008F-8B48-92A6-B652298478BF}" type="slidenum">
               <a:rPr lang="en-US" smtClean="0"/>
-              <a:t>‹#›</a:t>
+              <a:t>‹N°›</a:t>
             </a:fld>
             <a:endParaRPr lang="en-US"/>
           </a:p>
@@ -2623,10 +2620,9 @@
           <a:lstStyle/>
           <a:p>
             <a:r>
-              <a:rPr lang="en-US" smtClean="0"/>
+              <a:rPr lang="en-US"/>
               <a:t>Click to edit Master title style</a:t>
             </a:r>
-            <a:endParaRPr lang="en-US"/>
           </a:p>
         </p:txBody>
       </p:sp>
@@ -2657,38 +2653,37 @@
           <a:p>
             <a:pPr lvl="0"/>
             <a:r>
-              <a:rPr lang="en-US" smtClean="0"/>
+              <a:rPr lang="en-US"/>
               <a:t>Click to edit Master text styles</a:t>
             </a:r>
           </a:p>
           <a:p>
             <a:pPr lvl="1"/>
             <a:r>
-              <a:rPr lang="en-US" smtClean="0"/>
+              <a:rPr lang="en-US"/>
               <a:t>Second level</a:t>
             </a:r>
           </a:p>
           <a:p>
             <a:pPr lvl="2"/>
             <a:r>
-              <a:rPr lang="en-US" smtClean="0"/>
+              <a:rPr lang="en-US"/>
               <a:t>Third level</a:t>
             </a:r>
           </a:p>
           <a:p>
             <a:pPr lvl="3"/>
             <a:r>
-              <a:rPr lang="en-US" smtClean="0"/>
+              <a:rPr lang="en-US"/>
               <a:t>Fourth level</a:t>
             </a:r>
           </a:p>
           <a:p>
             <a:pPr lvl="4"/>
             <a:r>
-              <a:rPr lang="en-US" smtClean="0"/>
+              <a:rPr lang="en-US"/>
               <a:t>Fifth level</a:t>
             </a:r>
-            <a:endParaRPr lang="en-US"/>
           </a:p>
         </p:txBody>
       </p:sp>
@@ -2727,7 +2722,7 @@
           <a:p>
             <a:fld id="{5BCAD085-E8A6-8845-BD4E-CB4CCA059FC4}" type="datetimeFigureOut">
               <a:rPr lang="en-US" smtClean="0"/>
-              <a:t>1/27/13</a:t>
+              <a:t>6/23/2026</a:t>
             </a:fld>
             <a:endParaRPr lang="en-US"/>
           </a:p>
@@ -2805,7 +2800,7 @@
           <a:p>
             <a:fld id="{C1FF6DA9-008F-8B48-92A6-B652298478BF}" type="slidenum">
               <a:rPr lang="en-US" smtClean="0"/>
-              <a:t>‹#›</a:t>
+              <a:t>‹N°›</a:t>
             </a:fld>
             <a:endParaRPr lang="en-US"/>
           </a:p>
@@ -3086,7 +3081,7 @@
 </file>
 
 <file path=ppt/slides/slide1.xml><?xml version="1.0" encoding="utf-8"?>
-<p:sld xmlns:a="http://schemas.openxmlformats.org/drawingml/2006/main" xmlns:p="http://schemas.openxmlformats.org/presentationml/2006/main" xmlns:r="http://schemas.openxmlformats.org/officeDocument/2006/relationships">
+<p:sld xmlns:a="http://schemas.openxmlformats.org/drawingml/2006/main" xmlns:r="http://schemas.openxmlformats.org/officeDocument/2006/relationships" xmlns:p="http://schemas.openxmlformats.org/presentationml/2006/main">
   <p:cSld>
     <p:bg>
       <p:bgPr>
@@ -3102,7 +3097,14 @@
         <p:cNvGrpSpPr/>
         <p:nvPr/>
       </p:nvGrpSpPr>
-      <p:grpSpPr/>
+      <p:grpSpPr>
+        <a:xfrm>
+          <a:off x="0" y="0"/>
+          <a:ext cx="0" cy="0"/>
+          <a:chOff x="0" y="0"/>
+          <a:chExt cx="0" cy="0"/>
+        </a:xfrm>
+      </p:grpSpPr>
       <p:sp>
         <p:nvSpPr>
           <p:cNvPr id="2" name="TextBox 1"/>
@@ -3248,7 +3250,7 @@
 </file>
 
 <file path=ppt/slides/slide2.xml><?xml version="1.0" encoding="utf-8"?>
-<p:sld xmlns:a="http://schemas.openxmlformats.org/drawingml/2006/main" xmlns:p="http://schemas.openxmlformats.org/presentationml/2006/main" xmlns:r="http://schemas.openxmlformats.org/officeDocument/2006/relationships">
+<p:sld xmlns:a="http://schemas.openxmlformats.org/drawingml/2006/main" xmlns:r="http://schemas.openxmlformats.org/officeDocument/2006/relationships" xmlns:p="http://schemas.openxmlformats.org/presentationml/2006/main">
   <p:cSld>
     <p:bg>
       <p:bgPr>
@@ -3264,7 +3266,14 @@
         <p:cNvGrpSpPr/>
         <p:nvPr/>
       </p:nvGrpSpPr>
-      <p:grpSpPr/>
+      <p:grpSpPr>
+        <a:xfrm>
+          <a:off x="0" y="0"/>
+          <a:ext cx="0" cy="0"/>
+          <a:chOff x="0" y="0"/>
+          <a:chExt cx="0" cy="0"/>
+        </a:xfrm>
+      </p:grpSpPr>
       <p:sp>
         <p:nvSpPr>
           <p:cNvPr id="2" name="TextBox 1"/>
@@ -3379,6 +3388,7 @@
           <a:lstStyle/>
           <a:p>
             <a:pPr algn="ctr"/>
+            <a:endParaRPr/>
           </a:p>
         </p:txBody>
       </p:sp>
@@ -3408,7 +3418,7 @@
               <a:spcAft>
                 <a:spcPts val="1500"/>
               </a:spcAft>
-              <a:defRPr b="1" sz="1400">
+              <a:defRPr sz="1400" b="1">
                 <a:solidFill>
                   <a:srgbClr val="1F2D3D"/>
                 </a:solidFill>
@@ -3524,6 +3534,36 @@
           </a:p>
         </p:txBody>
       </p:sp>
+      <p:pic>
+        <p:nvPicPr>
+          <p:cNvPr id="6" name="Picture 2" descr="logo.png">
+            <a:extLst>
+              <a:ext uri="{FF2B5EF4-FFF2-40B4-BE49-F238E27FC236}">
+                <a16:creationId xmlns:a16="http://schemas.microsoft.com/office/drawing/2014/main" id="{C711A063-C378-6E7F-360A-5C3BF0F6241A}"/>
+              </a:ext>
+            </a:extLst>
+          </p:cNvPr>
+          <p:cNvPicPr>
+            <a:picLocks noChangeAspect="1"/>
+          </p:cNvPicPr>
+          <p:nvPr/>
+        </p:nvPicPr>
+        <p:blipFill>
+          <a:blip r:embed="rId2"/>
+          <a:stretch>
+            <a:fillRect/>
+          </a:stretch>
+        </p:blipFill>
+        <p:spPr>
+          <a:xfrm>
+            <a:off x="9601200" y="57150"/>
+            <a:ext cx="2377440" cy="713232"/>
+          </a:xfrm>
+          <a:prstGeom prst="rect">
+            <a:avLst/>
+          </a:prstGeom>
+        </p:spPr>
+      </p:pic>
     </p:spTree>
   </p:cSld>
   <p:clrMapOvr>
@@ -3533,7 +3573,7 @@
 </file>
 
 <file path=ppt/slides/slide3.xml><?xml version="1.0" encoding="utf-8"?>
-<p:sld xmlns:a="http://schemas.openxmlformats.org/drawingml/2006/main" xmlns:p="http://schemas.openxmlformats.org/presentationml/2006/main" xmlns:r="http://schemas.openxmlformats.org/officeDocument/2006/relationships">
+<p:sld xmlns:a="http://schemas.openxmlformats.org/drawingml/2006/main" xmlns:r="http://schemas.openxmlformats.org/officeDocument/2006/relationships" xmlns:p="http://schemas.openxmlformats.org/presentationml/2006/main">
   <p:cSld>
     <p:bg>
       <p:bgPr>
@@ -3549,7 +3589,14 @@
         <p:cNvGrpSpPr/>
         <p:nvPr/>
       </p:nvGrpSpPr>
-      <p:grpSpPr/>
+      <p:grpSpPr>
+        <a:xfrm>
+          <a:off x="0" y="0"/>
+          <a:ext cx="0" cy="0"/>
+          <a:chOff x="0" y="0"/>
+          <a:chExt cx="0" cy="0"/>
+        </a:xfrm>
+      </p:grpSpPr>
       <p:sp>
         <p:nvSpPr>
           <p:cNvPr id="2" name="TextBox 1"/>
@@ -3664,6 +3711,7 @@
           <a:lstStyle/>
           <a:p>
             <a:pPr algn="ctr"/>
+            <a:endParaRPr/>
           </a:p>
         </p:txBody>
       </p:sp>
@@ -3693,7 +3741,7 @@
               <a:spcAft>
                 <a:spcPts val="1500"/>
               </a:spcAft>
-              <a:defRPr b="1" sz="1400">
+              <a:defRPr sz="1400" b="1">
                 <a:solidFill>
                   <a:srgbClr val="1F2D3D"/>
                 </a:solidFill>
@@ -3809,6 +3857,36 @@
           </a:p>
         </p:txBody>
       </p:sp>
+      <p:pic>
+        <p:nvPicPr>
+          <p:cNvPr id="6" name="Picture 2" descr="logo.png">
+            <a:extLst>
+              <a:ext uri="{FF2B5EF4-FFF2-40B4-BE49-F238E27FC236}">
+                <a16:creationId xmlns:a16="http://schemas.microsoft.com/office/drawing/2014/main" id="{68383985-8E64-3738-857C-C85BA7DF205A}"/>
+              </a:ext>
+            </a:extLst>
+          </p:cNvPr>
+          <p:cNvPicPr>
+            <a:picLocks noChangeAspect="1"/>
+          </p:cNvPicPr>
+          <p:nvPr/>
+        </p:nvPicPr>
+        <p:blipFill>
+          <a:blip r:embed="rId2"/>
+          <a:stretch>
+            <a:fillRect/>
+          </a:stretch>
+        </p:blipFill>
+        <p:spPr>
+          <a:xfrm>
+            <a:off x="9601200" y="57150"/>
+            <a:ext cx="2377440" cy="713232"/>
+          </a:xfrm>
+          <a:prstGeom prst="rect">
+            <a:avLst/>
+          </a:prstGeom>
+        </p:spPr>
+      </p:pic>
     </p:spTree>
   </p:cSld>
   <p:clrMapOvr>
@@ -3818,7 +3896,7 @@
 </file>
 
 <file path=ppt/slides/slide4.xml><?xml version="1.0" encoding="utf-8"?>
-<p:sld xmlns:a="http://schemas.openxmlformats.org/drawingml/2006/main" xmlns:p="http://schemas.openxmlformats.org/presentationml/2006/main" xmlns:r="http://schemas.openxmlformats.org/officeDocument/2006/relationships">
+<p:sld xmlns:a="http://schemas.openxmlformats.org/drawingml/2006/main" xmlns:r="http://schemas.openxmlformats.org/officeDocument/2006/relationships" xmlns:p="http://schemas.openxmlformats.org/presentationml/2006/main">
   <p:cSld>
     <p:bg>
       <p:bgPr>
@@ -3834,7 +3912,14 @@
         <p:cNvGrpSpPr/>
         <p:nvPr/>
       </p:nvGrpSpPr>
-      <p:grpSpPr/>
+      <p:grpSpPr>
+        <a:xfrm>
+          <a:off x="0" y="0"/>
+          <a:ext cx="0" cy="0"/>
+          <a:chOff x="0" y="0"/>
+          <a:chExt cx="0" cy="0"/>
+        </a:xfrm>
+      </p:grpSpPr>
       <p:sp>
         <p:nvSpPr>
           <p:cNvPr id="2" name="TextBox 1"/>
@@ -3949,6 +4034,7 @@
           <a:lstStyle/>
           <a:p>
             <a:pPr algn="ctr"/>
+            <a:endParaRPr/>
           </a:p>
         </p:txBody>
       </p:sp>
@@ -3978,7 +4064,7 @@
               <a:spcAft>
                 <a:spcPts val="1500"/>
               </a:spcAft>
-              <a:defRPr b="1" sz="1400">
+              <a:defRPr sz="1400" b="1">
                 <a:solidFill>
                   <a:srgbClr val="1F2D3D"/>
                 </a:solidFill>
@@ -4094,6 +4180,36 @@
           </a:p>
         </p:txBody>
       </p:sp>
+      <p:pic>
+        <p:nvPicPr>
+          <p:cNvPr id="6" name="Picture 2" descr="logo.png">
+            <a:extLst>
+              <a:ext uri="{FF2B5EF4-FFF2-40B4-BE49-F238E27FC236}">
+                <a16:creationId xmlns:a16="http://schemas.microsoft.com/office/drawing/2014/main" id="{0107B514-52B6-407C-C7BA-C2F46D0412CC}"/>
+              </a:ext>
+            </a:extLst>
+          </p:cNvPr>
+          <p:cNvPicPr>
+            <a:picLocks noChangeAspect="1"/>
+          </p:cNvPicPr>
+          <p:nvPr/>
+        </p:nvPicPr>
+        <p:blipFill>
+          <a:blip r:embed="rId2"/>
+          <a:stretch>
+            <a:fillRect/>
+          </a:stretch>
+        </p:blipFill>
+        <p:spPr>
+          <a:xfrm>
+            <a:off x="9601200" y="57150"/>
+            <a:ext cx="2377440" cy="713232"/>
+          </a:xfrm>
+          <a:prstGeom prst="rect">
+            <a:avLst/>
+          </a:prstGeom>
+        </p:spPr>
+      </p:pic>
     </p:spTree>
   </p:cSld>
   <p:clrMapOvr>
@@ -4103,7 +4219,7 @@
 </file>
 
 <file path=ppt/slides/slide5.xml><?xml version="1.0" encoding="utf-8"?>
-<p:sld xmlns:a="http://schemas.openxmlformats.org/drawingml/2006/main" xmlns:p="http://schemas.openxmlformats.org/presentationml/2006/main" xmlns:r="http://schemas.openxmlformats.org/officeDocument/2006/relationships">
+<p:sld xmlns:a="http://schemas.openxmlformats.org/drawingml/2006/main" xmlns:r="http://schemas.openxmlformats.org/officeDocument/2006/relationships" xmlns:p="http://schemas.openxmlformats.org/presentationml/2006/main">
   <p:cSld>
     <p:bg>
       <p:bgPr>
@@ -4119,7 +4235,14 @@
         <p:cNvGrpSpPr/>
         <p:nvPr/>
       </p:nvGrpSpPr>
-      <p:grpSpPr/>
+      <p:grpSpPr>
+        <a:xfrm>
+          <a:off x="0" y="0"/>
+          <a:ext cx="0" cy="0"/>
+          <a:chOff x="0" y="0"/>
+          <a:chExt cx="0" cy="0"/>
+        </a:xfrm>
+      </p:grpSpPr>
       <p:sp>
         <p:nvSpPr>
           <p:cNvPr id="2" name="TextBox 1"/>
@@ -4234,6 +4357,7 @@
           <a:lstStyle/>
           <a:p>
             <a:pPr algn="ctr"/>
+            <a:endParaRPr/>
           </a:p>
         </p:txBody>
       </p:sp>
@@ -4263,7 +4387,7 @@
               <a:spcAft>
                 <a:spcPts val="1500"/>
               </a:spcAft>
-              <a:defRPr b="1" sz="1400">
+              <a:defRPr sz="1400" b="1">
                 <a:solidFill>
                   <a:srgbClr val="1F2D3D"/>
                 </a:solidFill>
@@ -4333,6 +4457,36 @@
           </a:p>
         </p:txBody>
       </p:sp>
+      <p:pic>
+        <p:nvPicPr>
+          <p:cNvPr id="6" name="Picture 2" descr="logo.png">
+            <a:extLst>
+              <a:ext uri="{FF2B5EF4-FFF2-40B4-BE49-F238E27FC236}">
+                <a16:creationId xmlns:a16="http://schemas.microsoft.com/office/drawing/2014/main" id="{87E9380B-88E1-A6C8-B467-E7B58876C23B}"/>
+              </a:ext>
+            </a:extLst>
+          </p:cNvPr>
+          <p:cNvPicPr>
+            <a:picLocks noChangeAspect="1"/>
+          </p:cNvPicPr>
+          <p:nvPr/>
+        </p:nvPicPr>
+        <p:blipFill>
+          <a:blip r:embed="rId2"/>
+          <a:stretch>
+            <a:fillRect/>
+          </a:stretch>
+        </p:blipFill>
+        <p:spPr>
+          <a:xfrm>
+            <a:off x="9601200" y="57150"/>
+            <a:ext cx="2377440" cy="713232"/>
+          </a:xfrm>
+          <a:prstGeom prst="rect">
+            <a:avLst/>
+          </a:prstGeom>
+        </p:spPr>
+      </p:pic>
     </p:spTree>
   </p:cSld>
   <p:clrMapOvr>
@@ -4342,7 +4496,7 @@
 </file>
 
 <file path=ppt/slides/slide6.xml><?xml version="1.0" encoding="utf-8"?>
-<p:sld xmlns:a="http://schemas.openxmlformats.org/drawingml/2006/main" xmlns:p="http://schemas.openxmlformats.org/presentationml/2006/main" xmlns:r="http://schemas.openxmlformats.org/officeDocument/2006/relationships">
+<p:sld xmlns:a="http://schemas.openxmlformats.org/drawingml/2006/main" xmlns:r="http://schemas.openxmlformats.org/officeDocument/2006/relationships" xmlns:p="http://schemas.openxmlformats.org/presentationml/2006/main">
   <p:cSld>
     <p:bg>
       <p:bgPr>
@@ -4358,7 +4512,14 @@
         <p:cNvGrpSpPr/>
         <p:nvPr/>
       </p:nvGrpSpPr>
-      <p:grpSpPr/>
+      <p:grpSpPr>
+        <a:xfrm>
+          <a:off x="0" y="0"/>
+          <a:ext cx="0" cy="0"/>
+          <a:chOff x="0" y="0"/>
+          <a:chExt cx="0" cy="0"/>
+        </a:xfrm>
+      </p:grpSpPr>
       <p:sp>
         <p:nvSpPr>
           <p:cNvPr id="2" name="TextBox 1"/>
@@ -4473,6 +4634,7 @@
           <a:lstStyle/>
           <a:p>
             <a:pPr algn="ctr"/>
+            <a:endParaRPr/>
           </a:p>
         </p:txBody>
       </p:sp>
@@ -4502,7 +4664,7 @@
               <a:spcAft>
                 <a:spcPts val="1500"/>
               </a:spcAft>
-              <a:defRPr b="1" sz="1400">
+              <a:defRPr sz="1400" b="1">
                 <a:solidFill>
                   <a:srgbClr val="1F2D3D"/>
                 </a:solidFill>
@@ -4571,6 +4733,36 @@
           </a:p>
         </p:txBody>
       </p:sp>
+      <p:pic>
+        <p:nvPicPr>
+          <p:cNvPr id="6" name="Picture 2" descr="logo.png">
+            <a:extLst>
+              <a:ext uri="{FF2B5EF4-FFF2-40B4-BE49-F238E27FC236}">
+                <a16:creationId xmlns:a16="http://schemas.microsoft.com/office/drawing/2014/main" id="{C080305D-A568-ED3B-1DD5-24671D3C9045}"/>
+              </a:ext>
+            </a:extLst>
+          </p:cNvPr>
+          <p:cNvPicPr>
+            <a:picLocks noChangeAspect="1"/>
+          </p:cNvPicPr>
+          <p:nvPr/>
+        </p:nvPicPr>
+        <p:blipFill>
+          <a:blip r:embed="rId2"/>
+          <a:stretch>
+            <a:fillRect/>
+          </a:stretch>
+        </p:blipFill>
+        <p:spPr>
+          <a:xfrm>
+            <a:off x="9601200" y="57150"/>
+            <a:ext cx="2377440" cy="713232"/>
+          </a:xfrm>
+          <a:prstGeom prst="rect">
+            <a:avLst/>
+          </a:prstGeom>
+        </p:spPr>
+      </p:pic>
     </p:spTree>
   </p:cSld>
   <p:clrMapOvr>
@@ -4580,7 +4772,7 @@
 </file>
 
 <file path=ppt/slides/slide7.xml><?xml version="1.0" encoding="utf-8"?>
-<p:sld xmlns:a="http://schemas.openxmlformats.org/drawingml/2006/main" xmlns:p="http://schemas.openxmlformats.org/presentationml/2006/main" xmlns:r="http://schemas.openxmlformats.org/officeDocument/2006/relationships">
+<p:sld xmlns:a="http://schemas.openxmlformats.org/drawingml/2006/main" xmlns:r="http://schemas.openxmlformats.org/officeDocument/2006/relationships" xmlns:p="http://schemas.openxmlformats.org/presentationml/2006/main">
   <p:cSld>
     <p:bg>
       <p:bgPr>
@@ -4596,7 +4788,14 @@
         <p:cNvGrpSpPr/>
         <p:nvPr/>
       </p:nvGrpSpPr>
-      <p:grpSpPr/>
+      <p:grpSpPr>
+        <a:xfrm>
+          <a:off x="0" y="0"/>
+          <a:ext cx="0" cy="0"/>
+          <a:chOff x="0" y="0"/>
+          <a:chExt cx="0" cy="0"/>
+        </a:xfrm>
+      </p:grpSpPr>
       <p:sp>
         <p:nvSpPr>
           <p:cNvPr id="2" name="TextBox 1"/>
@@ -4711,6 +4910,7 @@
           <a:lstStyle/>
           <a:p>
             <a:pPr algn="ctr"/>
+            <a:endParaRPr/>
           </a:p>
         </p:txBody>
       </p:sp>
@@ -4740,7 +4940,7 @@
               <a:spcAft>
                 <a:spcPts val="1500"/>
               </a:spcAft>
-              <a:defRPr b="1" sz="1400">
+              <a:defRPr sz="1400" b="1">
                 <a:solidFill>
                   <a:srgbClr val="1F2D3D"/>
                 </a:solidFill>
@@ -4830,6 +5030,36 @@
           </a:p>
         </p:txBody>
       </p:sp>
+      <p:pic>
+        <p:nvPicPr>
+          <p:cNvPr id="6" name="Picture 2" descr="logo.png">
+            <a:extLst>
+              <a:ext uri="{FF2B5EF4-FFF2-40B4-BE49-F238E27FC236}">
+                <a16:creationId xmlns:a16="http://schemas.microsoft.com/office/drawing/2014/main" id="{4BE8DAED-A300-615A-B007-681F033C3C65}"/>
+              </a:ext>
+            </a:extLst>
+          </p:cNvPr>
+          <p:cNvPicPr>
+            <a:picLocks noChangeAspect="1"/>
+          </p:cNvPicPr>
+          <p:nvPr/>
+        </p:nvPicPr>
+        <p:blipFill>
+          <a:blip r:embed="rId2"/>
+          <a:stretch>
+            <a:fillRect/>
+          </a:stretch>
+        </p:blipFill>
+        <p:spPr>
+          <a:xfrm>
+            <a:off x="9601200" y="57150"/>
+            <a:ext cx="2377440" cy="713232"/>
+          </a:xfrm>
+          <a:prstGeom prst="rect">
+            <a:avLst/>
+          </a:prstGeom>
+        </p:spPr>
+      </p:pic>
     </p:spTree>
   </p:cSld>
   <p:clrMapOvr>
@@ -4839,7 +5069,7 @@
 </file>
 
 <file path=ppt/slides/slide8.xml><?xml version="1.0" encoding="utf-8"?>
-<p:sld xmlns:a="http://schemas.openxmlformats.org/drawingml/2006/main" xmlns:p="http://schemas.openxmlformats.org/presentationml/2006/main" xmlns:r="http://schemas.openxmlformats.org/officeDocument/2006/relationships">
+<p:sld xmlns:a="http://schemas.openxmlformats.org/drawingml/2006/main" xmlns:r="http://schemas.openxmlformats.org/officeDocument/2006/relationships" xmlns:p="http://schemas.openxmlformats.org/presentationml/2006/main">
   <p:cSld>
     <p:bg>
       <p:bgPr>
@@ -4855,7 +5085,14 @@
         <p:cNvGrpSpPr/>
         <p:nvPr/>
       </p:nvGrpSpPr>
-      <p:grpSpPr/>
+      <p:grpSpPr>
+        <a:xfrm>
+          <a:off x="0" y="0"/>
+          <a:ext cx="0" cy="0"/>
+          <a:chOff x="0" y="0"/>
+          <a:chExt cx="0" cy="0"/>
+        </a:xfrm>
+      </p:grpSpPr>
       <p:sp>
         <p:nvSpPr>
           <p:cNvPr id="2" name="TextBox 1"/>
@@ -5017,6 +5254,36 @@
           <a:xfrm>
             <a:off x="6705295" y="0"/>
             <a:ext cx="5486400" cy="6858000"/>
+          </a:xfrm>
+          <a:prstGeom prst="rect">
+            <a:avLst/>
+          </a:prstGeom>
+        </p:spPr>
+      </p:pic>
+      <p:pic>
+        <p:nvPicPr>
+          <p:cNvPr id="4" name="Picture 2" descr="logo.png">
+            <a:extLst>
+              <a:ext uri="{FF2B5EF4-FFF2-40B4-BE49-F238E27FC236}">
+                <a16:creationId xmlns:a16="http://schemas.microsoft.com/office/drawing/2014/main" id="{089C5338-3509-A57C-7A5E-8C3FE3CBD6D4}"/>
+              </a:ext>
+            </a:extLst>
+          </p:cNvPr>
+          <p:cNvPicPr>
+            <a:picLocks noChangeAspect="1"/>
+          </p:cNvPicPr>
+          <p:nvPr/>
+        </p:nvPicPr>
+        <p:blipFill>
+          <a:blip r:embed="rId3"/>
+          <a:stretch>
+            <a:fillRect/>
+          </a:stretch>
+        </p:blipFill>
+        <p:spPr>
+          <a:xfrm>
+            <a:off x="8055864" y="0"/>
+            <a:ext cx="3253740" cy="976122"/>
           </a:xfrm>
           <a:prstGeom prst="rect">
             <a:avLst/>

</xml_diff>